<commit_message>
docs: melhora figura framework
</commit_message>
<xml_diff>
--- a/figura framework.pptx
+++ b/figura framework.pptx
@@ -134,7 +134,7 @@
       </p:grpSpPr>
       <p:sp>
         <p:nvSpPr>
-          <p:cNvPr id="1057123982" name="Espaço reservado para cabeçalho 1"/>
+          <p:cNvPr id="1097009520" name="Espaço reservado para cabeçalho 1"/>
           <p:cNvSpPr>
             <a:spLocks noGrp="1"/>
           </p:cNvSpPr>
@@ -168,7 +168,7 @@
       </p:sp>
       <p:sp>
         <p:nvSpPr>
-          <p:cNvPr id="1249772928" name="Marcador de Posição da Data 2"/>
+          <p:cNvPr id="604314076" name="Marcador de Posição da Data 2"/>
           <p:cNvSpPr>
             <a:spLocks noGrp="1"/>
           </p:cNvSpPr>
@@ -206,7 +206,7 @@
       </p:sp>
       <p:sp>
         <p:nvSpPr>
-          <p:cNvPr id="1452365531" name="Espaço reservado para imagem de slide 3"/>
+          <p:cNvPr id="590837250" name="Espaço reservado para imagem de slide 3"/>
           <p:cNvSpPr>
             <a:spLocks noChangeAspect="1" noGrp="1" noRot="1"/>
           </p:cNvSpPr>
@@ -242,7 +242,7 @@
       </p:sp>
       <p:sp>
         <p:nvSpPr>
-          <p:cNvPr id="1638464505" name="Espaço reservado para notas 4"/>
+          <p:cNvPr id="1812531680" name="Espaço reservado para notas 4"/>
           <p:cNvSpPr>
             <a:spLocks noGrp="1"/>
           </p:cNvSpPr>
@@ -316,7 +316,7 @@
       </p:sp>
       <p:sp>
         <p:nvSpPr>
-          <p:cNvPr id="670122838" name="Marcador de Posição do Rodapé 5"/>
+          <p:cNvPr id="2025880354" name="Marcador de Posição do Rodapé 5"/>
           <p:cNvSpPr>
             <a:spLocks noGrp="1"/>
           </p:cNvSpPr>
@@ -350,7 +350,7 @@
       </p:sp>
       <p:sp>
         <p:nvSpPr>
-          <p:cNvPr id="1451028160" name="Marcador de Posição do Número do Diapositivo 6"/>
+          <p:cNvPr id="973875931" name="Marcador de Posição do Número do Diapositivo 6"/>
           <p:cNvSpPr>
             <a:spLocks noGrp="1"/>
           </p:cNvSpPr>
@@ -503,7 +503,7 @@
       </p:grpSpPr>
       <p:sp>
         <p:nvSpPr>
-          <p:cNvPr id="304457758" name="Espaço reservado para imagem de slide 1"/>
+          <p:cNvPr id="149096713" name="Espaço reservado para imagem de slide 1"/>
           <p:cNvSpPr>
             <a:spLocks noChangeAspect="1" noGrp="1" noRot="1"/>
           </p:cNvSpPr>
@@ -520,7 +520,7 @@
       </p:sp>
       <p:sp>
         <p:nvSpPr>
-          <p:cNvPr id="958704571" name="Espaço reservado para notas 2"/>
+          <p:cNvPr id="1791739104" name="Espaço reservado para notas 2"/>
           <p:cNvSpPr>
             <a:spLocks noGrp="1"/>
           </p:cNvSpPr>
@@ -545,7 +545,7 @@
       </p:sp>
       <p:sp>
         <p:nvSpPr>
-          <p:cNvPr id="1192717016" name="Marcador de Posição do Número do Diapositivo 3"/>
+          <p:cNvPr id="377680319" name="Marcador de Posição do Número do Diapositivo 3"/>
           <p:cNvSpPr>
             <a:spLocks noGrp="1"/>
           </p:cNvSpPr>
@@ -596,7 +596,7 @@
       </p:grpSpPr>
       <p:sp>
         <p:nvSpPr>
-          <p:cNvPr id="1075607309" name="Título 1"/>
+          <p:cNvPr id="370519112" name="Título 1"/>
           <p:cNvSpPr>
             <a:spLocks noGrp="1"/>
           </p:cNvSpPr>
@@ -631,7 +631,7 @@
       </p:sp>
       <p:sp>
         <p:nvSpPr>
-          <p:cNvPr id="1826961263" name="Subtítulo 2"/>
+          <p:cNvPr id="1822919408" name="Subtítulo 2"/>
           <p:cNvSpPr>
             <a:spLocks noGrp="1"/>
           </p:cNvSpPr>
@@ -699,7 +699,7 @@
       </p:sp>
       <p:sp>
         <p:nvSpPr>
-          <p:cNvPr id="985721631" name="Marcador de Posição da Data 3"/>
+          <p:cNvPr id="1797585835" name="Marcador de Posição da Data 3"/>
           <p:cNvSpPr>
             <a:spLocks noGrp="1"/>
           </p:cNvSpPr>
@@ -725,7 +725,7 @@
       </p:sp>
       <p:sp>
         <p:nvSpPr>
-          <p:cNvPr id="2115981158" name="Marcador de Posição do Rodapé 4"/>
+          <p:cNvPr id="291616676" name="Marcador de Posição do Rodapé 4"/>
           <p:cNvSpPr>
             <a:spLocks noGrp="1"/>
           </p:cNvSpPr>
@@ -747,7 +747,7 @@
       </p:sp>
       <p:sp>
         <p:nvSpPr>
-          <p:cNvPr id="2056907601" name="Marcador de Posição do Número do Diapositivo 5"/>
+          <p:cNvPr id="648706307" name="Marcador de Posição do Número do Diapositivo 5"/>
           <p:cNvSpPr>
             <a:spLocks noGrp="1"/>
           </p:cNvSpPr>
@@ -798,7 +798,7 @@
       </p:grpSpPr>
       <p:sp>
         <p:nvSpPr>
-          <p:cNvPr id="662278498" name="Título 1"/>
+          <p:cNvPr id="289346673" name="Título 1"/>
           <p:cNvSpPr>
             <a:spLocks noGrp="1"/>
           </p:cNvSpPr>
@@ -824,7 +824,7 @@
       </p:sp>
       <p:sp>
         <p:nvSpPr>
-          <p:cNvPr id="1439367130" name="Marcador de Posição de Texto Vertical 2"/>
+          <p:cNvPr id="342524377" name="Marcador de Posição de Texto Vertical 2"/>
           <p:cNvSpPr>
             <a:spLocks noGrp="1"/>
           </p:cNvSpPr>
@@ -890,7 +890,7 @@
       </p:sp>
       <p:sp>
         <p:nvSpPr>
-          <p:cNvPr id="801427124" name="Marcador de Posição da Data 3"/>
+          <p:cNvPr id="119971175" name="Marcador de Posição da Data 3"/>
           <p:cNvSpPr>
             <a:spLocks noGrp="1"/>
           </p:cNvSpPr>
@@ -916,7 +916,7 @@
       </p:sp>
       <p:sp>
         <p:nvSpPr>
-          <p:cNvPr id="239686764" name="Marcador de Posição do Rodapé 4"/>
+          <p:cNvPr id="870657117" name="Marcador de Posição do Rodapé 4"/>
           <p:cNvSpPr>
             <a:spLocks noGrp="1"/>
           </p:cNvSpPr>
@@ -938,7 +938,7 @@
       </p:sp>
       <p:sp>
         <p:nvSpPr>
-          <p:cNvPr id="999199512" name="Marcador de Posição do Número do Diapositivo 5"/>
+          <p:cNvPr id="546553272" name="Marcador de Posição do Número do Diapositivo 5"/>
           <p:cNvSpPr>
             <a:spLocks noGrp="1"/>
           </p:cNvSpPr>
@@ -989,7 +989,7 @@
       </p:grpSpPr>
       <p:sp>
         <p:nvSpPr>
-          <p:cNvPr id="783451140" name="Título Vertical 1"/>
+          <p:cNvPr id="1676534731" name="Título Vertical 1"/>
           <p:cNvSpPr>
             <a:spLocks noGrp="1"/>
           </p:cNvSpPr>
@@ -1020,7 +1020,7 @@
       </p:sp>
       <p:sp>
         <p:nvSpPr>
-          <p:cNvPr id="848744064" name="Marcador de Posição de Texto Vertical 2"/>
+          <p:cNvPr id="1615291756" name="Marcador de Posição de Texto Vertical 2"/>
           <p:cNvSpPr>
             <a:spLocks noGrp="1"/>
           </p:cNvSpPr>
@@ -1091,7 +1091,7 @@
       </p:sp>
       <p:sp>
         <p:nvSpPr>
-          <p:cNvPr id="2023014674" name="Marcador de Posição da Data 3"/>
+          <p:cNvPr id="1362943464" name="Marcador de Posição da Data 3"/>
           <p:cNvSpPr>
             <a:spLocks noGrp="1"/>
           </p:cNvSpPr>
@@ -1117,7 +1117,7 @@
       </p:sp>
       <p:sp>
         <p:nvSpPr>
-          <p:cNvPr id="1414290896" name="Marcador de Posição do Rodapé 4"/>
+          <p:cNvPr id="380166418" name="Marcador de Posição do Rodapé 4"/>
           <p:cNvSpPr>
             <a:spLocks noGrp="1"/>
           </p:cNvSpPr>
@@ -1139,7 +1139,7 @@
       </p:sp>
       <p:sp>
         <p:nvSpPr>
-          <p:cNvPr id="834489500" name="Marcador de Posição do Número do Diapositivo 5"/>
+          <p:cNvPr id="1906027120" name="Marcador de Posição do Número do Diapositivo 5"/>
           <p:cNvSpPr>
             <a:spLocks noGrp="1"/>
           </p:cNvSpPr>
@@ -1190,7 +1190,7 @@
       </p:grpSpPr>
       <p:sp>
         <p:nvSpPr>
-          <p:cNvPr id="1179988138" name="Título 1"/>
+          <p:cNvPr id="121853099" name="Título 1"/>
           <p:cNvSpPr>
             <a:spLocks noGrp="1"/>
           </p:cNvSpPr>
@@ -1216,7 +1216,7 @@
       </p:sp>
       <p:sp>
         <p:nvSpPr>
-          <p:cNvPr id="1716070357" name="Marcador de Posição de Conteúdo 2"/>
+          <p:cNvPr id="1124813996" name="Marcador de Posição de Conteúdo 2"/>
           <p:cNvSpPr>
             <a:spLocks noGrp="1"/>
           </p:cNvSpPr>
@@ -1282,7 +1282,7 @@
       </p:sp>
       <p:sp>
         <p:nvSpPr>
-          <p:cNvPr id="1289241627" name="Marcador de Posição da Data 3"/>
+          <p:cNvPr id="1764867244" name="Marcador de Posição da Data 3"/>
           <p:cNvSpPr>
             <a:spLocks noGrp="1"/>
           </p:cNvSpPr>
@@ -1308,7 +1308,7 @@
       </p:sp>
       <p:sp>
         <p:nvSpPr>
-          <p:cNvPr id="1747540528" name="Marcador de Posição do Rodapé 4"/>
+          <p:cNvPr id="303189281" name="Marcador de Posição do Rodapé 4"/>
           <p:cNvSpPr>
             <a:spLocks noGrp="1"/>
           </p:cNvSpPr>
@@ -1330,7 +1330,7 @@
       </p:sp>
       <p:sp>
         <p:nvSpPr>
-          <p:cNvPr id="509182438" name="Marcador de Posição do Número do Diapositivo 5"/>
+          <p:cNvPr id="182006061" name="Marcador de Posição do Número do Diapositivo 5"/>
           <p:cNvSpPr>
             <a:spLocks noGrp="1"/>
           </p:cNvSpPr>
@@ -1381,7 +1381,7 @@
       </p:grpSpPr>
       <p:sp>
         <p:nvSpPr>
-          <p:cNvPr id="2130081951" name="Título 1"/>
+          <p:cNvPr id="1236977247" name="Título 1"/>
           <p:cNvSpPr>
             <a:spLocks noGrp="1"/>
           </p:cNvSpPr>
@@ -1416,7 +1416,7 @@
       </p:sp>
       <p:sp>
         <p:nvSpPr>
-          <p:cNvPr id="1188341880" name="Marcador de Posição do Texto 2"/>
+          <p:cNvPr id="856668601" name="Marcador de Posição do Texto 2"/>
           <p:cNvSpPr>
             <a:spLocks noGrp="1"/>
           </p:cNvSpPr>
@@ -1538,7 +1538,7 @@
       </p:sp>
       <p:sp>
         <p:nvSpPr>
-          <p:cNvPr id="607606324" name="Marcador de Posição da Data 3"/>
+          <p:cNvPr id="1012395411" name="Marcador de Posição da Data 3"/>
           <p:cNvSpPr>
             <a:spLocks noGrp="1"/>
           </p:cNvSpPr>
@@ -1564,7 +1564,7 @@
       </p:sp>
       <p:sp>
         <p:nvSpPr>
-          <p:cNvPr id="687128340" name="Marcador de Posição do Rodapé 4"/>
+          <p:cNvPr id="1164016949" name="Marcador de Posição do Rodapé 4"/>
           <p:cNvSpPr>
             <a:spLocks noGrp="1"/>
           </p:cNvSpPr>
@@ -1586,7 +1586,7 @@
       </p:sp>
       <p:sp>
         <p:nvSpPr>
-          <p:cNvPr id="969593078" name="Marcador de Posição do Número do Diapositivo 5"/>
+          <p:cNvPr id="1532465033" name="Marcador de Posição do Número do Diapositivo 5"/>
           <p:cNvSpPr>
             <a:spLocks noGrp="1"/>
           </p:cNvSpPr>
@@ -1637,7 +1637,7 @@
       </p:grpSpPr>
       <p:sp>
         <p:nvSpPr>
-          <p:cNvPr id="1457820456" name="Título 1"/>
+          <p:cNvPr id="143493702" name="Título 1"/>
           <p:cNvSpPr>
             <a:spLocks noGrp="1"/>
           </p:cNvSpPr>
@@ -1663,7 +1663,7 @@
       </p:sp>
       <p:sp>
         <p:nvSpPr>
-          <p:cNvPr id="1292257250" name="Marcador de Posição de Conteúdo 2"/>
+          <p:cNvPr id="857412897" name="Marcador de Posição de Conteúdo 2"/>
           <p:cNvSpPr>
             <a:spLocks noGrp="1"/>
           </p:cNvSpPr>
@@ -1734,7 +1734,7 @@
       </p:sp>
       <p:sp>
         <p:nvSpPr>
-          <p:cNvPr id="511984494" name="Marcador de Posição de Conteúdo 3"/>
+          <p:cNvPr id="525316886" name="Marcador de Posição de Conteúdo 3"/>
           <p:cNvSpPr>
             <a:spLocks noGrp="1"/>
           </p:cNvSpPr>
@@ -1805,7 +1805,7 @@
       </p:sp>
       <p:sp>
         <p:nvSpPr>
-          <p:cNvPr id="741363418" name="Marcador de Posição da Data 4"/>
+          <p:cNvPr id="2100778114" name="Marcador de Posição da Data 4"/>
           <p:cNvSpPr>
             <a:spLocks noGrp="1"/>
           </p:cNvSpPr>
@@ -1831,7 +1831,7 @@
       </p:sp>
       <p:sp>
         <p:nvSpPr>
-          <p:cNvPr id="1418764208" name="Marcador de Posição do Rodapé 5"/>
+          <p:cNvPr id="828412136" name="Marcador de Posição do Rodapé 5"/>
           <p:cNvSpPr>
             <a:spLocks noGrp="1"/>
           </p:cNvSpPr>
@@ -1853,7 +1853,7 @@
       </p:sp>
       <p:sp>
         <p:nvSpPr>
-          <p:cNvPr id="1213970725" name="Marcador de Posição do Número do Diapositivo 6"/>
+          <p:cNvPr id="2118380192" name="Marcador de Posição do Número do Diapositivo 6"/>
           <p:cNvSpPr>
             <a:spLocks noGrp="1"/>
           </p:cNvSpPr>
@@ -1904,7 +1904,7 @@
       </p:grpSpPr>
       <p:sp>
         <p:nvSpPr>
-          <p:cNvPr id="1649459652" name="Título 1"/>
+          <p:cNvPr id="187104570" name="Título 1"/>
           <p:cNvSpPr>
             <a:spLocks noGrp="1"/>
           </p:cNvSpPr>
@@ -1935,7 +1935,7 @@
       </p:sp>
       <p:sp>
         <p:nvSpPr>
-          <p:cNvPr id="1741676771" name="Marcador de Posição do Texto 2"/>
+          <p:cNvPr id="1490323832" name="Marcador de Posição do Texto 2"/>
           <p:cNvSpPr>
             <a:spLocks noGrp="1"/>
           </p:cNvSpPr>
@@ -2003,7 +2003,7 @@
       </p:sp>
       <p:sp>
         <p:nvSpPr>
-          <p:cNvPr id="197969039" name="Marcador de Posição de Conteúdo 3"/>
+          <p:cNvPr id="736560082" name="Marcador de Posição de Conteúdo 3"/>
           <p:cNvSpPr>
             <a:spLocks noGrp="1"/>
           </p:cNvSpPr>
@@ -2074,7 +2074,7 @@
       </p:sp>
       <p:sp>
         <p:nvSpPr>
-          <p:cNvPr id="867327928" name="Marcador de Posição do Texto 4"/>
+          <p:cNvPr id="83604358" name="Marcador de Posição do Texto 4"/>
           <p:cNvSpPr>
             <a:spLocks noGrp="1"/>
           </p:cNvSpPr>
@@ -2142,7 +2142,7 @@
       </p:sp>
       <p:sp>
         <p:nvSpPr>
-          <p:cNvPr id="442470457" name="Marcador de Posição de Conteúdo 5"/>
+          <p:cNvPr id="1789840274" name="Marcador de Posição de Conteúdo 5"/>
           <p:cNvSpPr>
             <a:spLocks noGrp="1"/>
           </p:cNvSpPr>
@@ -2213,7 +2213,7 @@
       </p:sp>
       <p:sp>
         <p:nvSpPr>
-          <p:cNvPr id="753728247" name="Marcador de Posição da Data 6"/>
+          <p:cNvPr id="951161325" name="Marcador de Posição da Data 6"/>
           <p:cNvSpPr>
             <a:spLocks noGrp="1"/>
           </p:cNvSpPr>
@@ -2239,7 +2239,7 @@
       </p:sp>
       <p:sp>
         <p:nvSpPr>
-          <p:cNvPr id="71239343" name="Marcador de Posição do Rodapé 7"/>
+          <p:cNvPr id="666944551" name="Marcador de Posição do Rodapé 7"/>
           <p:cNvSpPr>
             <a:spLocks noGrp="1"/>
           </p:cNvSpPr>
@@ -2261,7 +2261,7 @@
       </p:sp>
       <p:sp>
         <p:nvSpPr>
-          <p:cNvPr id="1951476525" name="Marcador de Posição do Número do Diapositivo 8"/>
+          <p:cNvPr id="1200848627" name="Marcador de Posição do Número do Diapositivo 8"/>
           <p:cNvSpPr>
             <a:spLocks noGrp="1"/>
           </p:cNvSpPr>
@@ -2312,7 +2312,7 @@
       </p:grpSpPr>
       <p:sp>
         <p:nvSpPr>
-          <p:cNvPr id="107743052" name="Título 1"/>
+          <p:cNvPr id="565063490" name="Título 1"/>
           <p:cNvSpPr>
             <a:spLocks noGrp="1"/>
           </p:cNvSpPr>
@@ -2338,7 +2338,7 @@
       </p:sp>
       <p:sp>
         <p:nvSpPr>
-          <p:cNvPr id="1745996300" name="Marcador de Posição da Data 2"/>
+          <p:cNvPr id="498119940" name="Marcador de Posição da Data 2"/>
           <p:cNvSpPr>
             <a:spLocks noGrp="1"/>
           </p:cNvSpPr>
@@ -2364,7 +2364,7 @@
       </p:sp>
       <p:sp>
         <p:nvSpPr>
-          <p:cNvPr id="1082132337" name="Marcador de Posição do Rodapé 3"/>
+          <p:cNvPr id="1675803360" name="Marcador de Posição do Rodapé 3"/>
           <p:cNvSpPr>
             <a:spLocks noGrp="1"/>
           </p:cNvSpPr>
@@ -2386,7 +2386,7 @@
       </p:sp>
       <p:sp>
         <p:nvSpPr>
-          <p:cNvPr id="196017772" name="Marcador de Posição do Número do Diapositivo 4"/>
+          <p:cNvPr id="144023836" name="Marcador de Posição do Número do Diapositivo 4"/>
           <p:cNvSpPr>
             <a:spLocks noGrp="1"/>
           </p:cNvSpPr>
@@ -2437,7 +2437,7 @@
       </p:grpSpPr>
       <p:sp>
         <p:nvSpPr>
-          <p:cNvPr id="1192117029" name="Marcador de Posição da Data 1"/>
+          <p:cNvPr id="92662534" name="Marcador de Posição da Data 1"/>
           <p:cNvSpPr>
             <a:spLocks noGrp="1"/>
           </p:cNvSpPr>
@@ -2463,7 +2463,7 @@
       </p:sp>
       <p:sp>
         <p:nvSpPr>
-          <p:cNvPr id="858054251" name="Marcador de Posição do Rodapé 2"/>
+          <p:cNvPr id="1800393555" name="Marcador de Posição do Rodapé 2"/>
           <p:cNvSpPr>
             <a:spLocks noGrp="1"/>
           </p:cNvSpPr>
@@ -2485,7 +2485,7 @@
       </p:sp>
       <p:sp>
         <p:nvSpPr>
-          <p:cNvPr id="156808033" name="Marcador de Posição do Número do Diapositivo 3"/>
+          <p:cNvPr id="1704475675" name="Marcador de Posição do Número do Diapositivo 3"/>
           <p:cNvSpPr>
             <a:spLocks noGrp="1"/>
           </p:cNvSpPr>
@@ -2536,7 +2536,7 @@
       </p:grpSpPr>
       <p:sp>
         <p:nvSpPr>
-          <p:cNvPr id="1913269039" name="Título 1"/>
+          <p:cNvPr id="598602134" name="Título 1"/>
           <p:cNvSpPr>
             <a:spLocks noGrp="1"/>
           </p:cNvSpPr>
@@ -2571,7 +2571,7 @@
       </p:sp>
       <p:sp>
         <p:nvSpPr>
-          <p:cNvPr id="976307672" name="Marcador de Posição de Conteúdo 2"/>
+          <p:cNvPr id="1895716090" name="Marcador de Posição de Conteúdo 2"/>
           <p:cNvSpPr>
             <a:spLocks noGrp="1"/>
           </p:cNvSpPr>
@@ -2670,7 +2670,7 @@
       </p:sp>
       <p:sp>
         <p:nvSpPr>
-          <p:cNvPr id="135984480" name="Marcador de Posição do Texto 3"/>
+          <p:cNvPr id="102772965" name="Marcador de Posição do Texto 3"/>
           <p:cNvSpPr>
             <a:spLocks noGrp="1"/>
           </p:cNvSpPr>
@@ -2738,7 +2738,7 @@
       </p:sp>
       <p:sp>
         <p:nvSpPr>
-          <p:cNvPr id="1639394694" name="Marcador de Posição da Data 4"/>
+          <p:cNvPr id="427929125" name="Marcador de Posição da Data 4"/>
           <p:cNvSpPr>
             <a:spLocks noGrp="1"/>
           </p:cNvSpPr>
@@ -2764,7 +2764,7 @@
       </p:sp>
       <p:sp>
         <p:nvSpPr>
-          <p:cNvPr id="265015553" name="Marcador de Posição do Rodapé 5"/>
+          <p:cNvPr id="213539881" name="Marcador de Posição do Rodapé 5"/>
           <p:cNvSpPr>
             <a:spLocks noGrp="1"/>
           </p:cNvSpPr>
@@ -2786,7 +2786,7 @@
       </p:sp>
       <p:sp>
         <p:nvSpPr>
-          <p:cNvPr id="1755870501" name="Marcador de Posição do Número do Diapositivo 6"/>
+          <p:cNvPr id="500481731" name="Marcador de Posição do Número do Diapositivo 6"/>
           <p:cNvSpPr>
             <a:spLocks noGrp="1"/>
           </p:cNvSpPr>
@@ -2837,7 +2837,7 @@
       </p:grpSpPr>
       <p:sp>
         <p:nvSpPr>
-          <p:cNvPr id="341869036" name="Título 1"/>
+          <p:cNvPr id="2119153094" name="Título 1"/>
           <p:cNvSpPr>
             <a:spLocks noGrp="1"/>
           </p:cNvSpPr>
@@ -2872,7 +2872,7 @@
       </p:sp>
       <p:sp>
         <p:nvSpPr>
-          <p:cNvPr id="632236456" name="Marcador de Posição da Imagem 2"/>
+          <p:cNvPr id="1020937146" name="Marcador de Posição da Imagem 2"/>
           <p:cNvSpPr>
             <a:spLocks noChangeAspect="1" noGrp="1"/>
           </p:cNvSpPr>
@@ -2940,7 +2940,7 @@
       </p:sp>
       <p:sp>
         <p:nvSpPr>
-          <p:cNvPr id="1218039134" name="Marcador de Posição do Texto 3"/>
+          <p:cNvPr id="1573128807" name="Marcador de Posição do Texto 3"/>
           <p:cNvSpPr>
             <a:spLocks noGrp="1"/>
           </p:cNvSpPr>
@@ -3008,7 +3008,7 @@
       </p:sp>
       <p:sp>
         <p:nvSpPr>
-          <p:cNvPr id="614784282" name="Marcador de Posição da Data 4"/>
+          <p:cNvPr id="1382210186" name="Marcador de Posição da Data 4"/>
           <p:cNvSpPr>
             <a:spLocks noGrp="1"/>
           </p:cNvSpPr>
@@ -3034,7 +3034,7 @@
       </p:sp>
       <p:sp>
         <p:nvSpPr>
-          <p:cNvPr id="1297378136" name="Marcador de Posição do Rodapé 5"/>
+          <p:cNvPr id="1197256568" name="Marcador de Posição do Rodapé 5"/>
           <p:cNvSpPr>
             <a:spLocks noGrp="1"/>
           </p:cNvSpPr>
@@ -3056,7 +3056,7 @@
       </p:sp>
       <p:sp>
         <p:nvSpPr>
-          <p:cNvPr id="1653347614" name="Marcador de Posição do Número do Diapositivo 6"/>
+          <p:cNvPr id="156419103" name="Marcador de Posição do Número do Diapositivo 6"/>
           <p:cNvSpPr>
             <a:spLocks noGrp="1"/>
           </p:cNvSpPr>
@@ -3112,7 +3112,7 @@
       </p:grpSpPr>
       <p:sp>
         <p:nvSpPr>
-          <p:cNvPr id="2037812381" name="Marcador de Posição do Título 1"/>
+          <p:cNvPr id="966083892" name="Marcador de Posição do Título 1"/>
           <p:cNvSpPr>
             <a:spLocks noGrp="1"/>
           </p:cNvSpPr>
@@ -3148,7 +3148,7 @@
       </p:sp>
       <p:sp>
         <p:nvSpPr>
-          <p:cNvPr id="540601013" name="Marcador de Posição do Texto 2"/>
+          <p:cNvPr id="1984656352" name="Marcador de Posição do Texto 2"/>
           <p:cNvSpPr>
             <a:spLocks noGrp="1"/>
           </p:cNvSpPr>
@@ -3224,7 +3224,7 @@
       </p:sp>
       <p:sp>
         <p:nvSpPr>
-          <p:cNvPr id="1359594671" name="Marcador de Posição da Data 3"/>
+          <p:cNvPr id="903109428" name="Marcador de Posição da Data 3"/>
           <p:cNvSpPr>
             <a:spLocks noGrp="1"/>
           </p:cNvSpPr>
@@ -3268,7 +3268,7 @@
       </p:sp>
       <p:sp>
         <p:nvSpPr>
-          <p:cNvPr id="1330377738" name="Marcador de Posição do Rodapé 4"/>
+          <p:cNvPr id="1199997041" name="Marcador de Posição do Rodapé 4"/>
           <p:cNvSpPr>
             <a:spLocks noGrp="1"/>
           </p:cNvSpPr>
@@ -3308,7 +3308,7 @@
       </p:sp>
       <p:sp>
         <p:nvSpPr>
-          <p:cNvPr id="944518731" name="Marcador de Posição do Número do Diapositivo 5"/>
+          <p:cNvPr id="2119710255" name="Marcador de Posição do Número do Diapositivo 5"/>
           <p:cNvSpPr>
             <a:spLocks noGrp="1"/>
           </p:cNvSpPr>
@@ -3668,7 +3668,7 @@
       </p:grpSpPr>
       <p:sp>
         <p:nvSpPr>
-          <p:cNvPr id="1751100054" name=""/>
+          <p:cNvPr id="1997739875" name=""/>
           <p:cNvSpPr/>
           <p:nvPr/>
         </p:nvSpPr>
@@ -3719,7 +3719,7 @@
       </p:sp>
       <p:sp>
         <p:nvSpPr>
-          <p:cNvPr id="1969347755" name=""/>
+          <p:cNvPr id="178923762" name=""/>
           <p:cNvSpPr/>
           <p:nvPr/>
         </p:nvSpPr>
@@ -3764,7 +3764,7 @@
       </p:sp>
       <p:sp>
         <p:nvSpPr>
-          <p:cNvPr id="1103859919" name=""/>
+          <p:cNvPr id="854938251" name=""/>
           <p:cNvSpPr/>
           <p:nvPr/>
         </p:nvSpPr>
@@ -3804,7 +3804,7 @@
       </p:sp>
       <p:sp>
         <p:nvSpPr>
-          <p:cNvPr id="1749524375" name=""/>
+          <p:cNvPr id="868023821" name=""/>
           <p:cNvSpPr/>
           <p:nvPr/>
         </p:nvSpPr>
@@ -3867,7 +3867,7 @@
       </p:sp>
       <p:grpSp>
         <p:nvGrpSpPr>
-          <p:cNvPr id="2053688173" name=""/>
+          <p:cNvPr id="1972304360" name=""/>
           <p:cNvGrpSpPr/>
           <p:nvPr/>
         </p:nvGrpSpPr>
@@ -5686,7 +5686,7 @@
       </p:grpSp>
       <p:sp>
         <p:nvSpPr>
-          <p:cNvPr id="1220888939" name=""/>
+          <p:cNvPr id="844462929" name=""/>
           <p:cNvSpPr txBox="1"/>
           <p:nvPr/>
         </p:nvSpPr>
@@ -5861,7 +5861,7 @@
       </p:sp>
       <p:grpSp>
         <p:nvGrpSpPr>
-          <p:cNvPr id="697715128" name=""/>
+          <p:cNvPr id="1260570200" name=""/>
           <p:cNvGrpSpPr/>
           <p:nvPr/>
         </p:nvGrpSpPr>
@@ -5979,7 +5979,7 @@
       </p:grpSp>
       <p:sp>
         <p:nvSpPr>
-          <p:cNvPr id="1493154094" name=""/>
+          <p:cNvPr id="669291335" name=""/>
           <p:cNvSpPr txBox="1"/>
           <p:nvPr/>
         </p:nvSpPr>
@@ -6160,7 +6160,7 @@
       </p:sp>
       <p:sp>
         <p:nvSpPr>
-          <p:cNvPr id="1272753108" name=""/>
+          <p:cNvPr id="1034973980" name=""/>
           <p:cNvSpPr/>
           <p:nvPr/>
         </p:nvSpPr>
@@ -6205,7 +6205,7 @@
       </p:sp>
       <p:sp>
         <p:nvSpPr>
-          <p:cNvPr id="1751751021" name=""/>
+          <p:cNvPr id="528033614" name=""/>
           <p:cNvSpPr/>
           <p:nvPr/>
         </p:nvSpPr>
@@ -6278,7 +6278,7 @@
       </p:sp>
       <p:sp>
         <p:nvSpPr>
-          <p:cNvPr id="2090184274" name=""/>
+          <p:cNvPr id="1486918923" name=""/>
           <p:cNvSpPr/>
           <p:nvPr/>
         </p:nvSpPr>
@@ -6329,7 +6329,7 @@
       </p:sp>
       <p:grpSp>
         <p:nvGrpSpPr>
-          <p:cNvPr id="789821538" name=""/>
+          <p:cNvPr id="1306707243" name=""/>
           <p:cNvGrpSpPr/>
           <p:nvPr/>
         </p:nvGrpSpPr>
@@ -6520,7 +6520,7 @@
       </p:grpSp>
       <p:grpSp>
         <p:nvGrpSpPr>
-          <p:cNvPr id="1025570006" name=""/>
+          <p:cNvPr id="309341186" name=""/>
           <p:cNvGrpSpPr/>
           <p:nvPr/>
         </p:nvGrpSpPr>
@@ -6801,14 +6801,14 @@
       </p:grpSp>
       <p:cxnSp>
         <p:nvCxnSpPr>
-          <p:cNvPr id="601337561" name=""/>
+          <p:cNvPr id="1369971352" name=""/>
           <p:cNvCxnSpPr/>
           <p:nvPr/>
         </p:nvCxnSpPr>
         <p:spPr bwMode="auto">
           <a:xfrm rot="5400000" flipH="1" flipV="0">
-            <a:off x="9083453" y="3228049"/>
-            <a:ext cx="695582" cy="142996"/>
+            <a:off x="9036842" y="3181438"/>
+            <a:ext cx="508816" cy="422980"/>
           </a:xfrm>
           <a:prstGeom prst="line">
             <a:avLst/>
@@ -6843,7 +6843,7 @@
       </p:cxnSp>
       <p:cxnSp>
         <p:nvCxnSpPr>
-          <p:cNvPr id="1800051441" name=""/>
+          <p:cNvPr id="1956097451" name=""/>
           <p:cNvCxnSpPr/>
           <p:nvPr/>
         </p:nvCxnSpPr>
@@ -6882,14 +6882,14 @@
       </p:cxnSp>
       <p:cxnSp>
         <p:nvCxnSpPr>
-          <p:cNvPr id="1008065092" name=""/>
+          <p:cNvPr id="1665905687" name=""/>
           <p:cNvCxnSpPr/>
           <p:nvPr/>
         </p:nvCxnSpPr>
         <p:spPr bwMode="auto">
-          <a:xfrm rot="5400000" flipH="0" flipV="0">
-            <a:off x="9919486" y="2056508"/>
-            <a:ext cx="95106" cy="744870"/>
+          <a:xfrm rot="5400000" flipH="1" flipV="0">
+            <a:off x="9920261" y="1962177"/>
+            <a:ext cx="0" cy="838423"/>
           </a:xfrm>
           <a:prstGeom prst="line">
             <a:avLst/>
@@ -6921,14 +6921,14 @@
       </p:cxnSp>
       <p:cxnSp>
         <p:nvCxnSpPr>
-          <p:cNvPr id="660968234" name=""/>
+          <p:cNvPr id="166694545" name=""/>
           <p:cNvCxnSpPr/>
           <p:nvPr/>
         </p:nvCxnSpPr>
         <p:spPr bwMode="auto">
           <a:xfrm rot="5400000" flipH="0" flipV="0">
-            <a:off x="10367337" y="2402063"/>
-            <a:ext cx="146103" cy="1094369"/>
+            <a:off x="10375476" y="2274937"/>
+            <a:ext cx="265087" cy="1229633"/>
           </a:xfrm>
           <a:prstGeom prst="line">
             <a:avLst/>
@@ -6960,14 +6960,14 @@
       </p:cxnSp>
       <p:cxnSp>
         <p:nvCxnSpPr>
-          <p:cNvPr id="97990804" name=""/>
+          <p:cNvPr id="137080194" name=""/>
           <p:cNvCxnSpPr/>
           <p:nvPr/>
         </p:nvCxnSpPr>
         <p:spPr bwMode="auto">
           <a:xfrm rot="5400000" flipH="1" flipV="0">
-            <a:off x="10413132" y="2306517"/>
-            <a:ext cx="494174" cy="645184"/>
+            <a:off x="10554550" y="2165097"/>
+            <a:ext cx="351362" cy="785210"/>
           </a:xfrm>
           <a:prstGeom prst="line">
             <a:avLst/>
@@ -7002,7 +7002,7 @@
       </p:cxnSp>
       <p:cxnSp>
         <p:nvCxnSpPr>
-          <p:cNvPr id="1146729688" name=""/>
+          <p:cNvPr id="1996684811" name=""/>
           <p:cNvCxnSpPr/>
           <p:nvPr/>
         </p:nvCxnSpPr>
@@ -7041,16 +7041,14 @@
       </p:cxnSp>
       <p:cxnSp>
         <p:nvCxnSpPr>
-          <p:cNvPr id="642262128" name=""/>
-          <p:cNvCxnSpPr>
-            <a:stCxn id="542480961" idx="3"/>
-          </p:cNvCxnSpPr>
+          <p:cNvPr id="2081226262" name=""/>
+          <p:cNvCxnSpPr/>
           <p:nvPr/>
         </p:nvCxnSpPr>
         <p:spPr bwMode="auto">
           <a:xfrm rot="5400000" flipH="0" flipV="0">
-            <a:off x="10456463" y="1796939"/>
-            <a:ext cx="440568" cy="724371"/>
+            <a:off x="10484800" y="1685932"/>
+            <a:ext cx="523236" cy="863715"/>
           </a:xfrm>
           <a:prstGeom prst="line">
             <a:avLst/>
@@ -7082,14 +7080,14 @@
       </p:cxnSp>
       <p:cxnSp>
         <p:nvCxnSpPr>
-          <p:cNvPr id="1547239650" name=""/>
+          <p:cNvPr id="1866147576" name=""/>
           <p:cNvCxnSpPr/>
           <p:nvPr/>
         </p:nvCxnSpPr>
         <p:spPr bwMode="auto">
           <a:xfrm rot="5400000" flipH="1" flipV="0">
-            <a:off x="9892325" y="1913119"/>
-            <a:ext cx="542064" cy="390022"/>
+            <a:off x="9852370" y="1873164"/>
+            <a:ext cx="730915" cy="281077"/>
           </a:xfrm>
           <a:prstGeom prst="line">
             <a:avLst/>
@@ -7121,14 +7119,14 @@
       </p:cxnSp>
       <p:cxnSp>
         <p:nvCxnSpPr>
-          <p:cNvPr id="1522400634" name=""/>
+          <p:cNvPr id="1267341486" name=""/>
           <p:cNvCxnSpPr/>
           <p:nvPr/>
         </p:nvCxnSpPr>
         <p:spPr bwMode="auto">
           <a:xfrm rot="5400000" flipH="1" flipV="0">
-            <a:off x="9348252" y="1216407"/>
-            <a:ext cx="397222" cy="842578"/>
+            <a:off x="9542994" y="1120186"/>
+            <a:ext cx="116874" cy="951715"/>
           </a:xfrm>
           <a:prstGeom prst="line">
             <a:avLst/>
@@ -7163,14 +7161,14 @@
       </p:cxnSp>
       <p:cxnSp>
         <p:nvCxnSpPr>
-          <p:cNvPr id="202558573" name=""/>
+          <p:cNvPr id="1929261610" name=""/>
           <p:cNvCxnSpPr/>
           <p:nvPr/>
         </p:nvCxnSpPr>
         <p:spPr bwMode="auto">
-          <a:xfrm rot="16199999" flipH="1" flipV="1">
-            <a:off x="10175271" y="1100722"/>
-            <a:ext cx="520322" cy="938771"/>
+          <a:xfrm rot="16199998" flipH="1" flipV="1">
+            <a:off x="10318786" y="1068449"/>
+            <a:ext cx="344534" cy="827527"/>
           </a:xfrm>
           <a:prstGeom prst="line">
             <a:avLst/>
@@ -7202,16 +7200,14 @@
       </p:cxnSp>
       <p:cxnSp>
         <p:nvCxnSpPr>
-          <p:cNvPr id="1927488477" name=""/>
-          <p:cNvCxnSpPr>
-            <a:stCxn id="542480961" idx="4"/>
-          </p:cNvCxnSpPr>
+          <p:cNvPr id="1920508643" name=""/>
+          <p:cNvCxnSpPr/>
           <p:nvPr/>
         </p:nvCxnSpPr>
         <p:spPr bwMode="auto">
           <a:xfrm rot="5400000" flipH="1" flipV="0">
-            <a:off x="10685904" y="1567389"/>
-            <a:ext cx="604507" cy="166338"/>
+            <a:off x="10787698" y="1465593"/>
+            <a:ext cx="507867" cy="273288"/>
           </a:xfrm>
           <a:prstGeom prst="line">
             <a:avLst/>
@@ -7243,16 +7239,14 @@
       </p:cxnSp>
       <p:cxnSp>
         <p:nvCxnSpPr>
-          <p:cNvPr id="2096995365" name=""/>
-          <p:cNvCxnSpPr>
-            <a:endCxn id="542480961" idx="3"/>
-          </p:cNvCxnSpPr>
+          <p:cNvPr id="1150170257" name=""/>
+          <p:cNvCxnSpPr/>
           <p:nvPr/>
         </p:nvCxnSpPr>
         <p:spPr bwMode="auto">
           <a:xfrm rot="10800000" flipH="0" flipV="0">
-            <a:off x="11038933" y="1938840"/>
-            <a:ext cx="588158" cy="135048"/>
+            <a:off x="11178276" y="1856171"/>
+            <a:ext cx="616761" cy="429660"/>
           </a:xfrm>
           <a:prstGeom prst="line">
             <a:avLst/>
@@ -7287,14 +7281,14 @@
       </p:cxnSp>
       <p:cxnSp>
         <p:nvCxnSpPr>
-          <p:cNvPr id="1241128044" name=""/>
+          <p:cNvPr id="614191481" name=""/>
           <p:cNvCxnSpPr/>
           <p:nvPr/>
         </p:nvCxnSpPr>
         <p:spPr bwMode="auto">
           <a:xfrm rot="5400000" flipH="0" flipV="0">
-            <a:off x="10936116" y="2144398"/>
-            <a:ext cx="791116" cy="650098"/>
+            <a:off x="11223248" y="2185421"/>
+            <a:ext cx="471378" cy="672200"/>
           </a:xfrm>
           <a:prstGeom prst="line">
             <a:avLst/>
@@ -7326,14 +7320,14 @@
       </p:cxnSp>
       <p:cxnSp>
         <p:nvCxnSpPr>
-          <p:cNvPr id="1306099372" name=""/>
+          <p:cNvPr id="934156565" name=""/>
           <p:cNvCxnSpPr/>
           <p:nvPr/>
         </p:nvCxnSpPr>
         <p:spPr bwMode="auto">
           <a:xfrm rot="5400000" flipH="0" flipV="1">
-            <a:off x="11242825" y="2487787"/>
-            <a:ext cx="973273" cy="145477"/>
+            <a:off x="11421535" y="2666496"/>
+            <a:ext cx="761328" cy="0"/>
           </a:xfrm>
           <a:prstGeom prst="line">
             <a:avLst/>
@@ -7365,14 +7359,14 @@
       </p:cxnSp>
       <p:cxnSp>
         <p:nvCxnSpPr>
-          <p:cNvPr id="191626111" name=""/>
+          <p:cNvPr id="925736187" name=""/>
           <p:cNvCxnSpPr/>
           <p:nvPr/>
         </p:nvCxnSpPr>
         <p:spPr bwMode="auto">
           <a:xfrm rot="5400000" flipH="1" flipV="0">
-            <a:off x="8830780" y="1733879"/>
-            <a:ext cx="1063866" cy="474277"/>
+            <a:off x="8927207" y="1808076"/>
+            <a:ext cx="816279" cy="309194"/>
           </a:xfrm>
           <a:prstGeom prst="line">
             <a:avLst/>
@@ -7404,14 +7398,14 @@
       </p:cxnSp>
       <p:cxnSp>
         <p:nvCxnSpPr>
-          <p:cNvPr id="1131466567" name=""/>
+          <p:cNvPr id="892474098" name=""/>
           <p:cNvCxnSpPr/>
           <p:nvPr/>
         </p:nvCxnSpPr>
         <p:spPr bwMode="auto">
           <a:xfrm rot="5400000" flipH="0" flipV="0">
-            <a:off x="9241014" y="2596393"/>
-            <a:ext cx="474095" cy="236630"/>
+            <a:off x="8900998" y="2549575"/>
+            <a:ext cx="767707" cy="410183"/>
           </a:xfrm>
           <a:prstGeom prst="line">
             <a:avLst/>
@@ -7443,14 +7437,14 @@
       </p:cxnSp>
       <p:cxnSp>
         <p:nvCxnSpPr>
-          <p:cNvPr id="2093476970" name=""/>
+          <p:cNvPr id="1585464844" name=""/>
           <p:cNvCxnSpPr/>
           <p:nvPr/>
         </p:nvCxnSpPr>
         <p:spPr bwMode="auto">
-          <a:xfrm rot="5400000" flipH="1" flipV="0">
-            <a:off x="9605073" y="2706430"/>
-            <a:ext cx="71940" cy="562593"/>
+          <a:xfrm rot="5400000" flipH="0" flipV="0">
+            <a:off x="9443637" y="2659819"/>
+            <a:ext cx="114824" cy="842578"/>
           </a:xfrm>
           <a:prstGeom prst="line">
             <a:avLst/>
@@ -7482,7 +7476,7 @@
       </p:cxnSp>
       <p:cxnSp>
         <p:nvCxnSpPr>
-          <p:cNvPr id="463378124" name=""/>
+          <p:cNvPr id="534028790" name=""/>
           <p:cNvCxnSpPr/>
           <p:nvPr/>
         </p:nvCxnSpPr>
@@ -7521,7 +7515,7 @@
       </p:cxnSp>
       <p:cxnSp>
         <p:nvCxnSpPr>
-          <p:cNvPr id="1054666489" name=""/>
+          <p:cNvPr id="948864725" name=""/>
           <p:cNvCxnSpPr/>
           <p:nvPr/>
         </p:nvCxnSpPr>
@@ -7560,14 +7554,14 @@
       </p:cxnSp>
       <p:cxnSp>
         <p:nvCxnSpPr>
-          <p:cNvPr id="1853025705" name=""/>
+          <p:cNvPr id="1152679465" name=""/>
           <p:cNvCxnSpPr/>
           <p:nvPr/>
         </p:nvCxnSpPr>
         <p:spPr bwMode="auto">
-          <a:xfrm rot="5400000" flipH="1" flipV="0">
-            <a:off x="10646238" y="3209650"/>
-            <a:ext cx="818038" cy="154415"/>
+          <a:xfrm rot="16199999" flipH="0" flipV="1">
+            <a:off x="10641625" y="3205037"/>
+            <a:ext cx="981676" cy="0"/>
           </a:xfrm>
           <a:prstGeom prst="line">
             <a:avLst/>
@@ -7599,14 +7593,14 @@
       </p:cxnSp>
       <p:cxnSp>
         <p:nvCxnSpPr>
-          <p:cNvPr id="796234683" name=""/>
+          <p:cNvPr id="259938677" name=""/>
           <p:cNvCxnSpPr/>
           <p:nvPr/>
         </p:nvCxnSpPr>
         <p:spPr bwMode="auto">
           <a:xfrm rot="5400000" flipH="1" flipV="1">
-            <a:off x="8454701" y="1865340"/>
-            <a:ext cx="1097127" cy="244618"/>
+            <a:off x="8513008" y="1779196"/>
+            <a:ext cx="900259" cy="435223"/>
           </a:xfrm>
           <a:prstGeom prst="line">
             <a:avLst/>
@@ -7638,14 +7632,14 @@
       </p:cxnSp>
       <p:cxnSp>
         <p:nvCxnSpPr>
-          <p:cNvPr id="827154108" name=""/>
+          <p:cNvPr id="798428054" name=""/>
           <p:cNvCxnSpPr/>
           <p:nvPr/>
         </p:nvCxnSpPr>
         <p:spPr bwMode="auto">
           <a:xfrm rot="5400000" flipH="1" flipV="0">
-            <a:off x="8908499" y="2499014"/>
-            <a:ext cx="455618" cy="446874"/>
+            <a:off x="8566852" y="2625612"/>
+            <a:ext cx="691582" cy="334234"/>
           </a:xfrm>
           <a:prstGeom prst="line">
             <a:avLst/>
@@ -7677,7 +7671,7 @@
       </p:cxnSp>
       <p:pic>
         <p:nvPicPr>
-          <p:cNvPr id="76318668" name=""/>
+          <p:cNvPr id="1067258835" name=""/>
           <p:cNvPicPr>
             <a:picLocks noChangeAspect="1"/>
           </p:cNvPicPr>
@@ -7699,7 +7693,7 @@
       </p:pic>
       <p:pic>
         <p:nvPicPr>
-          <p:cNvPr id="1637821467" name=""/>
+          <p:cNvPr id="1901010141" name=""/>
           <p:cNvPicPr>
             <a:picLocks noChangeAspect="1"/>
           </p:cNvPicPr>
@@ -7711,7 +7705,7 @@
         </p:blipFill>
         <p:spPr bwMode="auto">
           <a:xfrm rot="0" flipH="0" flipV="0">
-            <a:off x="11702535" y="2723771"/>
+            <a:off x="11771904" y="2824098"/>
             <a:ext cx="290956" cy="266043"/>
           </a:xfrm>
           <a:prstGeom prst="rect">
@@ -7721,7 +7715,7 @@
       </p:pic>
       <p:pic>
         <p:nvPicPr>
-          <p:cNvPr id="1258225530" name=""/>
+          <p:cNvPr id="208567524" name=""/>
           <p:cNvPicPr>
             <a:picLocks noChangeAspect="1"/>
           </p:cNvPicPr>
@@ -7733,7 +7727,7 @@
         </p:blipFill>
         <p:spPr bwMode="auto">
           <a:xfrm rot="0" flipH="0" flipV="0">
-            <a:off x="11040718" y="1668949"/>
+            <a:off x="11099682" y="1569162"/>
             <a:ext cx="290956" cy="266043"/>
           </a:xfrm>
           <a:prstGeom prst="rect">
@@ -7743,7 +7737,7 @@
       </p:pic>
       <p:pic>
         <p:nvPicPr>
-          <p:cNvPr id="456458446" name=""/>
+          <p:cNvPr id="201789351" name=""/>
           <p:cNvPicPr>
             <a:picLocks noChangeAspect="1"/>
           </p:cNvPicPr>
@@ -7755,7 +7749,7 @@
         </p:blipFill>
         <p:spPr bwMode="auto">
           <a:xfrm rot="0" flipH="0" flipV="0">
-            <a:off x="9469548" y="2162899"/>
+            <a:off x="9397239" y="2057065"/>
             <a:ext cx="290956" cy="266043"/>
           </a:xfrm>
           <a:prstGeom prst="rect">
@@ -7765,7 +7759,7 @@
       </p:pic>
       <p:pic>
         <p:nvPicPr>
-          <p:cNvPr id="1647985178" name=""/>
+          <p:cNvPr id="1011078527" name=""/>
           <p:cNvPicPr>
             <a:picLocks noChangeAspect="1"/>
           </p:cNvPicPr>
@@ -7787,7 +7781,7 @@
       </p:pic>
       <p:sp>
         <p:nvSpPr>
-          <p:cNvPr id="1691949128" name=""/>
+          <p:cNvPr id="486922569" name=""/>
           <p:cNvSpPr/>
           <p:nvPr/>
         </p:nvSpPr>
@@ -7835,7 +7829,7 @@
       </p:sp>
       <p:cxnSp>
         <p:nvCxnSpPr>
-          <p:cNvPr id="573476461" name=""/>
+          <p:cNvPr id="8809027" name=""/>
           <p:cNvCxnSpPr/>
           <p:nvPr/>
         </p:nvCxnSpPr>
@@ -7877,7 +7871,7 @@
       </p:cxnSp>
       <p:sp>
         <p:nvSpPr>
-          <p:cNvPr id="669817634" name=""/>
+          <p:cNvPr id="1685662879" name=""/>
           <p:cNvSpPr/>
           <p:nvPr/>
         </p:nvSpPr>
@@ -7925,7 +7919,7 @@
       </p:sp>
       <p:sp>
         <p:nvSpPr>
-          <p:cNvPr id="1813001526" name=""/>
+          <p:cNvPr id="1160352243" name=""/>
           <p:cNvSpPr/>
           <p:nvPr/>
         </p:nvSpPr>
@@ -7973,13 +7967,13 @@
       </p:sp>
       <p:sp>
         <p:nvSpPr>
-          <p:cNvPr id="1827016949" name=""/>
+          <p:cNvPr id="2049484206" name=""/>
           <p:cNvSpPr/>
           <p:nvPr/>
         </p:nvSpPr>
         <p:spPr bwMode="auto">
           <a:xfrm rot="0" flipH="0" flipV="0">
-            <a:off x="11610911" y="2026186"/>
+            <a:off x="11749226" y="2238129"/>
             <a:ext cx="91624" cy="95407"/>
           </a:xfrm>
           <a:prstGeom prst="ellipse">
@@ -8021,13 +8015,13 @@
       </p:sp>
       <p:sp>
         <p:nvSpPr>
-          <p:cNvPr id="806104657" name=""/>
+          <p:cNvPr id="1440365621" name=""/>
           <p:cNvSpPr/>
           <p:nvPr/>
         </p:nvSpPr>
         <p:spPr bwMode="auto">
           <a:xfrm rot="0" flipH="0" flipV="0">
-            <a:off x="10933891" y="2833726"/>
+            <a:off x="11090632" y="2695900"/>
             <a:ext cx="91624" cy="95406"/>
           </a:xfrm>
           <a:prstGeom prst="ellipse">
@@ -8069,13 +8063,13 @@
       </p:sp>
       <p:sp>
         <p:nvSpPr>
-          <p:cNvPr id="2040354331" name=""/>
+          <p:cNvPr id="1725201011" name=""/>
           <p:cNvSpPr/>
           <p:nvPr/>
         </p:nvSpPr>
         <p:spPr bwMode="auto">
           <a:xfrm rot="0" flipH="0" flipV="0">
-            <a:off x="9079761" y="1391381"/>
+            <a:off x="9125410" y="1506830"/>
             <a:ext cx="91625" cy="95408"/>
           </a:xfrm>
           <a:prstGeom prst="ellipse">
@@ -8117,13 +8111,13 @@
       </p:sp>
       <p:sp>
         <p:nvSpPr>
-          <p:cNvPr id="114762096" name=""/>
+          <p:cNvPr id="1779162300" name=""/>
           <p:cNvSpPr/>
           <p:nvPr/>
         </p:nvSpPr>
         <p:spPr bwMode="auto">
           <a:xfrm rot="0" flipH="0" flipV="0">
-            <a:off x="8867536" y="2454777"/>
+            <a:off x="8699714" y="2399234"/>
             <a:ext cx="91624" cy="95407"/>
           </a:xfrm>
           <a:prstGeom prst="ellipse">
@@ -8165,13 +8159,13 @@
       </p:sp>
       <p:sp>
         <p:nvSpPr>
-          <p:cNvPr id="338074997" name=""/>
+          <p:cNvPr id="1669420868" name=""/>
           <p:cNvSpPr/>
           <p:nvPr/>
         </p:nvSpPr>
         <p:spPr bwMode="auto">
           <a:xfrm rot="0" flipH="0" flipV="0">
-            <a:off x="9313934" y="2904053"/>
+            <a:off x="9033786" y="3090817"/>
             <a:ext cx="91624" cy="95407"/>
           </a:xfrm>
           <a:prstGeom prst="ellipse">
@@ -8213,7 +8207,7 @@
       </p:sp>
       <p:sp>
         <p:nvSpPr>
-          <p:cNvPr id="1492488592" name=""/>
+          <p:cNvPr id="1960066162" name=""/>
           <p:cNvSpPr/>
           <p:nvPr/>
         </p:nvSpPr>
@@ -8261,13 +8255,13 @@
       </p:sp>
       <p:sp>
         <p:nvSpPr>
-          <p:cNvPr id="1866748309" name=""/>
+          <p:cNvPr id="1954166810" name=""/>
           <p:cNvSpPr/>
           <p:nvPr/>
         </p:nvSpPr>
         <p:spPr bwMode="auto">
           <a:xfrm rot="0" flipH="0" flipV="0">
-            <a:off x="9549966" y="2428944"/>
+            <a:off x="9444132" y="2323110"/>
             <a:ext cx="91624" cy="95406"/>
           </a:xfrm>
           <a:prstGeom prst="ellipse">
@@ -8309,13 +8303,13 @@
       </p:sp>
       <p:sp>
         <p:nvSpPr>
-          <p:cNvPr id="1936894504" name=""/>
+          <p:cNvPr id="31358157" name=""/>
           <p:cNvSpPr/>
           <p:nvPr/>
         </p:nvSpPr>
         <p:spPr bwMode="auto">
           <a:xfrm rot="0" flipH="0" flipV="0">
-            <a:off x="9921227" y="1782960"/>
+            <a:off x="10031477" y="1606777"/>
             <a:ext cx="91624" cy="95407"/>
           </a:xfrm>
           <a:prstGeom prst="ellipse">
@@ -8357,7 +8351,7 @@
       </p:sp>
       <p:sp>
         <p:nvSpPr>
-          <p:cNvPr id="1918714132" name=""/>
+          <p:cNvPr id="1677948763" name=""/>
           <p:cNvSpPr/>
           <p:nvPr/>
         </p:nvSpPr>
@@ -8405,13 +8399,13 @@
       </p:sp>
       <p:sp>
         <p:nvSpPr>
-          <p:cNvPr id="542480961" name=""/>
+          <p:cNvPr id="1246137614" name=""/>
           <p:cNvSpPr/>
           <p:nvPr/>
         </p:nvSpPr>
         <p:spPr bwMode="auto">
           <a:xfrm rot="0" flipH="0" flipV="0">
-            <a:off x="11020502" y="1867433"/>
+            <a:off x="11138430" y="1808468"/>
             <a:ext cx="91624" cy="95406"/>
           </a:xfrm>
           <a:prstGeom prst="ellipse">
@@ -8453,7 +8447,7 @@
       </p:sp>
       <p:sp>
         <p:nvSpPr>
-          <p:cNvPr id="74957922" name=""/>
+          <p:cNvPr id="1191197375" name=""/>
           <p:cNvSpPr/>
           <p:nvPr/>
         </p:nvSpPr>
@@ -8501,7 +8495,7 @@
       </p:sp>
       <p:sp>
         <p:nvSpPr>
-          <p:cNvPr id="74957922" name=""/>
+          <p:cNvPr id="257701947" name=""/>
           <p:cNvSpPr/>
           <p:nvPr/>
         </p:nvSpPr>
@@ -8549,7 +8543,7 @@
       </p:sp>
       <p:sp>
         <p:nvSpPr>
-          <p:cNvPr id="1681147054" name=""/>
+          <p:cNvPr id="941716761" name=""/>
           <p:cNvSpPr/>
           <p:nvPr/>
         </p:nvSpPr>

</xml_diff>